<commit_message>
Add CAN/LIN ​Frame Generator Icon
</commit_message>
<xml_diff>
--- a/docs/ADAS UX Library.pptx
+++ b/docs/ADAS UX Library.pptx
@@ -345,7 +345,7 @@
               <a:rPr lang="en-US" smtClean="0">
                 <a:latin typeface="Arial" panose="020B0604020202020204" pitchFamily="34" charset="0"/>
               </a:rPr>
-              <a:t>11/18/2025</a:t>
+              <a:t>11/25/2025</a:t>
             </a:fld>
             <a:endParaRPr lang="en-US">
               <a:latin typeface="Arial" panose="020B0604020202020204" pitchFamily="34" charset="0"/>
@@ -523,7 +523,7 @@
             <a:fld id="{6EA5B416-5F0F-4485-8D14-92CEBB19703D}" type="datetimeFigureOut">
               <a:rPr lang="en-US" smtClean="0"/>
               <a:pPr/>
-              <a:t>11/18/2025</a:t>
+              <a:t>11/25/2025</a:t>
             </a:fld>
             <a:endParaRPr lang="en-US"/>
           </a:p>
@@ -15337,6 +15337,41 @@
               <a:rPr lang="en-US" dirty="0"/>
               <a:t>NI-Switch​</a:t>
             </a:r>
+            <a:endParaRPr lang="hu-HU" dirty="0"/>
+          </a:p>
+          <a:p>
+            <a:pPr marL="285750" indent="-285750">
+              <a:lnSpc>
+                <a:spcPct val="250000"/>
+              </a:lnSpc>
+              <a:buFont typeface="Arial" panose="020B0604020202020204" pitchFamily="34" charset="0"/>
+              <a:buChar char="•"/>
+            </a:pPr>
+            <a:r>
+              <a:rPr lang="en-US" dirty="0"/>
+              <a:t>CAN/LIN ​</a:t>
+            </a:r>
+            <a:r>
+              <a:rPr lang="hu-HU" dirty="0" err="1"/>
+              <a:t>Frame</a:t>
+            </a:r>
+            <a:r>
+              <a:rPr lang="hu-HU" dirty="0"/>
+              <a:t> </a:t>
+            </a:r>
+            <a:r>
+              <a:rPr lang="hu-HU" dirty="0" err="1"/>
+              <a:t>Generator</a:t>
+            </a:r>
+            <a:endParaRPr lang="en-US" dirty="0"/>
+          </a:p>
+          <a:p>
+            <a:pPr>
+              <a:lnSpc>
+                <a:spcPct val="250000"/>
+              </a:lnSpc>
+            </a:pPr>
+            <a:endParaRPr lang="en-US" dirty="0"/>
           </a:p>
           <a:p>
             <a:endParaRPr lang="en-US" dirty="0"/>
@@ -15636,6 +15671,66 @@
         <p:spPr>
           <a:xfrm>
             <a:off x="4811485" y="4514480"/>
+            <a:ext cx="304800" cy="304800"/>
+          </a:xfrm>
+          <a:prstGeom prst="rect">
+            <a:avLst/>
+          </a:prstGeom>
+        </p:spPr>
+      </p:pic>
+      <p:pic>
+        <p:nvPicPr>
+          <p:cNvPr id="5" name="Kép 4">
+            <a:extLst>
+              <a:ext uri="{FF2B5EF4-FFF2-40B4-BE49-F238E27FC236}">
+                <a16:creationId xmlns:a16="http://schemas.microsoft.com/office/drawing/2014/main" id="{59A8E524-4B15-FAA8-05C6-C524BB3ED8EB}"/>
+              </a:ext>
+            </a:extLst>
+          </p:cNvPr>
+          <p:cNvPicPr>
+            <a:picLocks noChangeAspect="1"/>
+          </p:cNvPicPr>
+          <p:nvPr/>
+        </p:nvPicPr>
+        <p:blipFill>
+          <a:blip r:embed="rId12"/>
+          <a:stretch>
+            <a:fillRect/>
+          </a:stretch>
+        </p:blipFill>
+        <p:spPr>
+          <a:xfrm>
+            <a:off x="6023002" y="6061806"/>
+            <a:ext cx="304800" cy="304800"/>
+          </a:xfrm>
+          <a:prstGeom prst="rect">
+            <a:avLst/>
+          </a:prstGeom>
+        </p:spPr>
+      </p:pic>
+      <p:pic>
+        <p:nvPicPr>
+          <p:cNvPr id="7" name="Kép 6">
+            <a:extLst>
+              <a:ext uri="{FF2B5EF4-FFF2-40B4-BE49-F238E27FC236}">
+                <a16:creationId xmlns:a16="http://schemas.microsoft.com/office/drawing/2014/main" id="{F12CAA81-66C0-69E9-F73E-88C86709AD4D}"/>
+              </a:ext>
+            </a:extLst>
+          </p:cNvPr>
+          <p:cNvPicPr>
+            <a:picLocks noChangeAspect="1"/>
+          </p:cNvPicPr>
+          <p:nvPr/>
+        </p:nvPicPr>
+        <p:blipFill>
+          <a:blip r:embed="rId13"/>
+          <a:stretch>
+            <a:fillRect/>
+          </a:stretch>
+        </p:blipFill>
+        <p:spPr>
+          <a:xfrm>
+            <a:off x="4800196" y="6061806"/>
             <a:ext cx="304800" cy="304800"/>
           </a:xfrm>
           <a:prstGeom prst="rect">
@@ -19109,15 +19204,6 @@
 </file>
 
 <file path=customXml/item2.xml><?xml version="1.0" encoding="utf-8"?>
-<?mso-contentType ?>
-<FormTemplates xmlns="http://schemas.microsoft.com/sharepoint/v3/contenttype/forms">
-  <Display>DocumentLibraryForm</Display>
-  <Edit>DocumentLibraryForm</Edit>
-  <New>DocumentLibraryForm</New>
-</FormTemplates>
-</file>
-
-<file path=customXml/item3.xml><?xml version="1.0" encoding="utf-8"?>
 <p:properties xmlns:p="http://schemas.microsoft.com/office/2006/metadata/properties" xmlns:xsi="http://www.w3.org/2001/XMLSchema-instance" xmlns:pc="http://schemas.microsoft.com/office/infopath/2007/PartnerControls">
   <documentManagement>
     <TaxCatchAll xmlns="8fce7d85-8d8d-4fca-b2f0-fe43a4d368bb" xsi:nil="true"/>
@@ -19126,6 +19212,15 @@
     </lcf76f155ced4ddcb4097134ff3c332f>
   </documentManagement>
 </p:properties>
+</file>
+
+<file path=customXml/item3.xml><?xml version="1.0" encoding="utf-8"?>
+<?mso-contentType ?>
+<FormTemplates xmlns="http://schemas.microsoft.com/sharepoint/v3/contenttype/forms">
+  <Display>DocumentLibraryForm</Display>
+  <Edit>DocumentLibraryForm</Edit>
+  <New>DocumentLibraryForm</New>
+</FormTemplates>
 </file>
 
 <file path=customXml/itemProps1.xml><?xml version="1.0" encoding="utf-8"?>
@@ -19148,14 +19243,6 @@
 </file>
 
 <file path=customXml/itemProps2.xml><?xml version="1.0" encoding="utf-8"?>
-<ds:datastoreItem xmlns:ds="http://schemas.openxmlformats.org/officeDocument/2006/customXml" ds:itemID="{00CBB35F-53FC-4076-8459-961BE0C9D4D0}">
-  <ds:schemaRefs>
-    <ds:schemaRef ds:uri="http://schemas.microsoft.com/sharepoint/v3/contenttype/forms"/>
-  </ds:schemaRefs>
-</ds:datastoreItem>
-</file>
-
-<file path=customXml/itemProps3.xml><?xml version="1.0" encoding="utf-8"?>
 <ds:datastoreItem xmlns:ds="http://schemas.openxmlformats.org/officeDocument/2006/customXml" ds:itemID="{D81C1633-800C-49A1-B5C6-B24C04AC600E}">
   <ds:schemaRefs>
     <ds:schemaRef ds:uri="8fce7d85-8d8d-4fca-b2f0-fe43a4d368bb"/>
@@ -19172,6 +19259,14 @@
 </ds:datastoreItem>
 </file>
 
+<file path=customXml/itemProps3.xml><?xml version="1.0" encoding="utf-8"?>
+<ds:datastoreItem xmlns:ds="http://schemas.openxmlformats.org/officeDocument/2006/customXml" ds:itemID="{00CBB35F-53FC-4076-8459-961BE0C9D4D0}">
+  <ds:schemaRefs>
+    <ds:schemaRef ds:uri="http://schemas.microsoft.com/sharepoint/v3/contenttype/forms"/>
+  </ds:schemaRefs>
+</ds:datastoreItem>
+</file>
+
 <file path=docMetadata/LabelInfo.xml><?xml version="1.0" encoding="utf-8"?>
 <clbl:labelList xmlns:clbl="http://schemas.microsoft.com/office/2020/mipLabelMetadata">
   <clbl:label id="{d38901aa-f724-46bf-bb4f-aef09392934b}" enabled="1" method="Privileged" siteId="{eb06985d-06ca-4a17-81da-629ab99f6505}" removed="0"/>

</xml_diff>